<commit_message>
Recover Unit QRCode startup with a single guarded boot return
</commit_message>
<xml_diff>
--- a/docs/M5Stack_Inventory_Guide.pptx
+++ b/docs/M5Stack_Inventory_Guide.pptx
@@ -30,6 +30,7 @@
     <p:sldId xmlns:r="http://schemas.openxmlformats.org/officeDocument/2006/relationships" id="275" r:id="R6d190955e3bc4720"/>
     <p:sldId xmlns:r="http://schemas.openxmlformats.org/officeDocument/2006/relationships" id="276" r:id="Rfbe8211efeb44a70"/>
     <p:sldId xmlns:r="http://schemas.openxmlformats.org/officeDocument/2006/relationships" id="277" r:id="Rd6ef078fbf5e48c0"/>
+    <p:sldId xmlns:ns0="http://schemas.openxmlformats.org/officeDocument/2006/relationships" id="278" ns0:id="rId28"/>
   </p:sldIdLst>
   <p:sldSz cx="12192000" cy="6858000"/>
   <p:notesSz cx="6858000" cy="9144000"/>
@@ -27468,6 +27469,1167 @@
 </p:sld>
 </file>
 
+<file path=ppt/slides/slide23.xml><?xml version="1.0" encoding="utf-8"?>
+<p:sld xmlns:a="http://schemas.openxmlformats.org/drawingml/2006/main" xmlns:p="http://schemas.openxmlformats.org/presentationml/2006/main" xmlns:r="http://schemas.openxmlformats.org/officeDocument/2006/relationships">
+  <p:cSld>
+    <p:bg>
+      <p:bgPr>
+        <a:solidFill>
+          <a:srgbClr val="F4F7FA"/>
+        </a:solidFill>
+        <a:effectLst/>
+      </p:bgPr>
+    </p:bg>
+    <p:spTree>
+      <p:nvGrpSpPr>
+        <p:cNvPr id="1" name=""/>
+        <p:cNvGrpSpPr/>
+        <p:nvPr/>
+      </p:nvGrpSpPr>
+      <p:grpSpPr/>
+      <p:sp>
+        <p:nvSpPr>
+          <p:cNvPr id="2" name="Rectangle 1"/>
+          <p:cNvSpPr/>
+          <p:nvPr/>
+        </p:nvSpPr>
+        <p:spPr>
+          <a:xfrm>
+            <a:off x="0" y="0"/>
+            <a:ext cx="152400" cy="6858000"/>
+          </a:xfrm>
+          <a:prstGeom prst="rect">
+            <a:avLst/>
+          </a:prstGeom>
+          <a:solidFill>
+            <a:srgbClr val="00B8E6"/>
+          </a:solidFill>
+          <a:ln>
+            <a:noFill/>
+          </a:ln>
+        </p:spPr>
+        <p:style>
+          <a:lnRef idx="1">
+            <a:schemeClr val="accent1"/>
+          </a:lnRef>
+          <a:fillRef idx="3">
+            <a:schemeClr val="accent1"/>
+          </a:fillRef>
+          <a:effectRef idx="2">
+            <a:schemeClr val="accent1"/>
+          </a:effectRef>
+          <a:fontRef idx="minor">
+            <a:schemeClr val="lt1"/>
+          </a:fontRef>
+        </p:style>
+        <p:txBody>
+          <a:bodyPr rtlCol="0" anchor="ctr"/>
+          <a:lstStyle/>
+          <a:p>
+            <a:pPr algn="ctr"/>
+          </a:p>
+        </p:txBody>
+      </p:sp>
+      <p:sp>
+        <p:nvSpPr>
+          <p:cNvPr id="3" name="Rectangle 2"/>
+          <p:cNvSpPr/>
+          <p:nvPr/>
+        </p:nvSpPr>
+        <p:spPr>
+          <a:xfrm>
+            <a:off x="533400" y="6350000"/>
+            <a:ext cx="11125200" cy="12700"/>
+          </a:xfrm>
+          <a:prstGeom prst="rect">
+            <a:avLst/>
+          </a:prstGeom>
+          <a:solidFill>
+            <a:srgbClr val="D9E3EA"/>
+          </a:solidFill>
+          <a:ln>
+            <a:noFill/>
+          </a:ln>
+        </p:spPr>
+        <p:style>
+          <a:lnRef idx="1">
+            <a:schemeClr val="accent1"/>
+          </a:lnRef>
+          <a:fillRef idx="3">
+            <a:schemeClr val="accent1"/>
+          </a:fillRef>
+          <a:effectRef idx="2">
+            <a:schemeClr val="accent1"/>
+          </a:effectRef>
+          <a:fontRef idx="minor">
+            <a:schemeClr val="lt1"/>
+          </a:fontRef>
+        </p:style>
+        <p:txBody>
+          <a:bodyPr rtlCol="0" anchor="ctr"/>
+          <a:lstStyle/>
+          <a:p>
+            <a:pPr algn="ctr"/>
+          </a:p>
+        </p:txBody>
+      </p:sp>
+      <p:sp>
+        <p:nvSpPr>
+          <p:cNvPr id="4" name="TextBox 3"/>
+          <p:cNvSpPr txBox="1"/>
+          <p:nvPr/>
+        </p:nvSpPr>
+        <p:spPr>
+          <a:xfrm>
+            <a:off x="533400" y="304800"/>
+            <a:ext cx="11125200" cy="345440"/>
+          </a:xfrm>
+          <a:prstGeom prst="rect">
+            <a:avLst/>
+          </a:prstGeom>
+          <a:noFill/>
+        </p:spPr>
+        <p:txBody>
+          <a:bodyPr wrap="none" lIns="0" rIns="0" tIns="0" bIns="0">
+            <a:spAutoFit/>
+          </a:bodyPr>
+          <a:lstStyle/>
+          <a:p>
+            <a:pPr>
+              <a:lnSpc>
+                <a:spcPct val="145000"/>
+              </a:lnSpc>
+              <a:spcBef>
+                <a:spcPts val="0"/>
+              </a:spcBef>
+              <a:spcAft>
+                <a:spcPts val="0"/>
+              </a:spcAft>
+              <a:defRPr sz="1600" u="none">
+                <a:solidFill>
+                  <a:srgbClr val="356FF0"/>
+                </a:solidFill>
+                <a:latin typeface="Hiragino Sans"/>
+              </a:defRPr>
+            </a:pPr>
+            <a:r>
+              <a:t>付録  StickS3 / Unit QRCode</a:t>
+            </a:r>
+          </a:p>
+        </p:txBody>
+      </p:sp>
+      <p:sp>
+        <p:nvSpPr>
+          <p:cNvPr id="5" name="TextBox 4"/>
+          <p:cNvSpPr txBox="1"/>
+          <p:nvPr/>
+        </p:nvSpPr>
+        <p:spPr>
+          <a:xfrm>
+            <a:off x="533400" y="762000"/>
+            <a:ext cx="11125200" cy="566420"/>
+          </a:xfrm>
+          <a:prstGeom prst="rect">
+            <a:avLst/>
+          </a:prstGeom>
+          <a:noFill/>
+        </p:spPr>
+        <p:txBody>
+          <a:bodyPr wrap="none" lIns="0" rIns="0" tIns="0" bIns="0">
+            <a:spAutoFit/>
+          </a:bodyPr>
+          <a:lstStyle/>
+          <a:p>
+            <a:pPr>
+              <a:lnSpc>
+                <a:spcPct val="145000"/>
+              </a:lnSpc>
+              <a:spcBef>
+                <a:spcPts val="0"/>
+              </a:spcBef>
+              <a:spcAft>
+                <a:spcPts val="0"/>
+              </a:spcAft>
+              <a:defRPr sz="2800" u="none">
+                <a:solidFill>
+                  <a:srgbClr val="132333"/>
+                </a:solidFill>
+                <a:latin typeface="Hiragino Sans"/>
+              </a:defRPr>
+            </a:pPr>
+            <a:r>
+              <a:t>StickS3の起動確認と切り分け</a:t>
+            </a:r>
+          </a:p>
+        </p:txBody>
+      </p:sp>
+      <p:sp>
+        <p:nvSpPr>
+          <p:cNvPr id="6" name="TextBox 5"/>
+          <p:cNvSpPr txBox="1"/>
+          <p:nvPr/>
+        </p:nvSpPr>
+        <p:spPr>
+          <a:xfrm>
+            <a:off x="533400" y="1409700"/>
+            <a:ext cx="11125200" cy="290195"/>
+          </a:xfrm>
+          <a:prstGeom prst="rect">
+            <a:avLst/>
+          </a:prstGeom>
+          <a:noFill/>
+        </p:spPr>
+        <p:txBody>
+          <a:bodyPr wrap="none" lIns="0" rIns="0" tIns="0" bIns="0">
+            <a:spAutoFit/>
+          </a:bodyPr>
+          <a:lstStyle/>
+          <a:p>
+            <a:pPr>
+              <a:lnSpc>
+                <a:spcPct val="145000"/>
+              </a:lnSpc>
+              <a:spcBef>
+                <a:spcPts val="0"/>
+              </a:spcBef>
+              <a:spcAft>
+                <a:spcPts val="0"/>
+              </a:spcAft>
+              <a:defRPr sz="1300" u="none">
+                <a:solidFill>
+                  <a:srgbClr val="5C7182"/>
+                </a:solidFill>
+                <a:latin typeface="Hiragino Sans"/>
+              </a:defRPr>
+            </a:pPr>
+            <a:r>
+              <a:t>Unit起動時のブートモードから、電源を切り替えず通常の読取りへ戻すための機能です。</a:t>
+            </a:r>
+          </a:p>
+        </p:txBody>
+      </p:sp>
+      <p:sp>
+        <p:nvSpPr>
+          <p:cNvPr id="7" name="TextBox 6"/>
+          <p:cNvSpPr txBox="1"/>
+          <p:nvPr/>
+        </p:nvSpPr>
+        <p:spPr>
+          <a:xfrm>
+            <a:off x="533400" y="1981200"/>
+            <a:ext cx="5588000" cy="382270"/>
+          </a:xfrm>
+          <a:prstGeom prst="rect">
+            <a:avLst/>
+          </a:prstGeom>
+          <a:noFill/>
+        </p:spPr>
+        <p:txBody>
+          <a:bodyPr wrap="none" lIns="0" rIns="0" tIns="0" bIns="0">
+            <a:spAutoFit/>
+          </a:bodyPr>
+          <a:lstStyle/>
+          <a:p>
+            <a:pPr>
+              <a:lnSpc>
+                <a:spcPct val="145000"/>
+              </a:lnSpc>
+              <a:spcBef>
+                <a:spcPts val="0"/>
+              </a:spcBef>
+              <a:spcAft>
+                <a:spcPts val="0"/>
+              </a:spcAft>
+              <a:defRPr sz="1800" u="none">
+                <a:solidFill>
+                  <a:srgbClr val="356FF0"/>
+                </a:solidFill>
+                <a:latin typeface="Hiragino Sans"/>
+              </a:defRPr>
+            </a:pPr>
+            <a:r>
+              <a:t>READYになるまで</a:t>
+            </a:r>
+          </a:p>
+        </p:txBody>
+      </p:sp>
+      <p:sp>
+        <p:nvSpPr>
+          <p:cNvPr id="8" name="TextBox 7"/>
+          <p:cNvSpPr txBox="1"/>
+          <p:nvPr/>
+        </p:nvSpPr>
+        <p:spPr>
+          <a:xfrm>
+            <a:off x="533400" y="2438400"/>
+            <a:ext cx="5588000" cy="768985"/>
+          </a:xfrm>
+          <a:prstGeom prst="rect">
+            <a:avLst/>
+          </a:prstGeom>
+          <a:noFill/>
+        </p:spPr>
+        <p:txBody>
+          <a:bodyPr wrap="none" lIns="0" rIns="0" tIns="0" bIns="0">
+            <a:spAutoFit/>
+          </a:bodyPr>
+          <a:lstStyle/>
+          <a:p>
+            <a:pPr>
+              <a:lnSpc>
+                <a:spcPct val="145000"/>
+              </a:lnSpc>
+              <a:spcBef>
+                <a:spcPts val="0"/>
+              </a:spcBef>
+              <a:spcAft>
+                <a:spcPts val="0"/>
+              </a:spcAft>
+              <a:defRPr sz="1300" u="none">
+                <a:solidFill>
+                  <a:srgbClr val="132333"/>
+                </a:solidFill>
+                <a:latin typeface="Hiragino Sans"/>
+              </a:defRPr>
+            </a:pPr>
+            <a:r>
+              <a:t>① 初期化中もIRを消灯（GPIO46 LOW）</a:t>
+            </a:r>
+          </a:p>
+          <a:p>
+            <a:pPr>
+              <a:lnSpc>
+                <a:spcPct val="145000"/>
+              </a:lnSpc>
+              <a:spcBef>
+                <a:spcPts val="0"/>
+              </a:spcBef>
+              <a:spcAft>
+                <a:spcPts val="0"/>
+              </a:spcAft>
+              <a:defRPr sz="1300" u="none">
+                <a:solidFill>
+                  <a:srgbClr val="132333"/>
+                </a:solidFill>
+                <a:latin typeface="Hiragino Sans"/>
+              </a:defRPr>
+            </a:pPr>
+            <a:r>
+              <a:t>   最初の給電後800msは通信せず待つ</a:t>
+            </a:r>
+          </a:p>
+          <a:p>
+            <a:pPr>
+              <a:lnSpc>
+                <a:spcPct val="145000"/>
+              </a:lnSpc>
+              <a:spcBef>
+                <a:spcPts val="0"/>
+              </a:spcBef>
+              <a:spcAft>
+                <a:spcPts val="0"/>
+              </a:spcAft>
+              <a:defRPr sz="1300" u="none">
+                <a:solidFill>
+                  <a:srgbClr val="132333"/>
+                </a:solidFill>
+                <a:latin typeface="Hiragino Sans"/>
+              </a:defRPr>
+            </a:pPr>
+            <a:r>
+              <a:t>   正常0x21の設定を確認してREADYへ</a:t>
+            </a:r>
+          </a:p>
+        </p:txBody>
+      </p:sp>
+      <p:sp>
+        <p:nvSpPr>
+          <p:cNvPr id="9" name="TextBox 8"/>
+          <p:cNvSpPr txBox="1"/>
+          <p:nvPr/>
+        </p:nvSpPr>
+        <p:spPr>
+          <a:xfrm>
+            <a:off x="533400" y="3238500"/>
+            <a:ext cx="5588000" cy="768985"/>
+          </a:xfrm>
+          <a:prstGeom prst="rect">
+            <a:avLst/>
+          </a:prstGeom>
+          <a:noFill/>
+        </p:spPr>
+        <p:txBody>
+          <a:bodyPr wrap="none" lIns="0" rIns="0" tIns="0" bIns="0">
+            <a:spAutoFit/>
+          </a:bodyPr>
+          <a:lstStyle/>
+          <a:p>
+            <a:pPr>
+              <a:lnSpc>
+                <a:spcPct val="145000"/>
+              </a:lnSpc>
+              <a:spcBef>
+                <a:spcPts val="0"/>
+              </a:spcBef>
+              <a:spcAft>
+                <a:spcPts val="0"/>
+              </a:spcAft>
+              <a:defRPr sz="1300" u="none">
+                <a:solidFill>
+                  <a:srgbClr val="132333"/>
+                </a:solidFill>
+                <a:latin typeface="Hiragino Sans"/>
+              </a:defRPr>
+            </a:pPr>
+            <a:r>
+              <a:t>② ブート0x54だけが応答した場合</a:t>
+            </a:r>
+          </a:p>
+          <a:p>
+            <a:pPr>
+              <a:lnSpc>
+                <a:spcPct val="145000"/>
+              </a:lnSpc>
+              <a:spcBef>
+                <a:spcPts val="0"/>
+              </a:spcBef>
+              <a:spcAft>
+                <a:spcPts val="0"/>
+              </a:spcAft>
+              <a:defRPr sz="1300" u="none">
+                <a:solidFill>
+                  <a:srgbClr val="132333"/>
+                </a:solidFill>
+                <a:latin typeface="Hiragino Sans"/>
+              </a:defRPr>
+            </a:pPr>
+            <a:r>
+              <a:t>   復帰命令0x77を一度だけ送る</a:t>
+            </a:r>
+          </a:p>
+          <a:p>
+            <a:pPr>
+              <a:lnSpc>
+                <a:spcPct val="145000"/>
+              </a:lnSpc>
+              <a:spcBef>
+                <a:spcPts val="0"/>
+              </a:spcBef>
+              <a:spcAft>
+                <a:spcPts val="0"/>
+              </a:spcAft>
+              <a:defRPr sz="1300" u="none">
+                <a:solidFill>
+                  <a:srgbClr val="132333"/>
+                </a:solidFill>
+                <a:latin typeface="Hiragino Sans"/>
+              </a:defRPr>
+            </a:pPr>
+            <a:r>
+              <a:t>   電源は切り替えない</a:t>
+            </a:r>
+          </a:p>
+        </p:txBody>
+      </p:sp>
+      <p:sp>
+        <p:nvSpPr>
+          <p:cNvPr id="10" name="TextBox 9"/>
+          <p:cNvSpPr txBox="1"/>
+          <p:nvPr/>
+        </p:nvSpPr>
+        <p:spPr>
+          <a:xfrm>
+            <a:off x="533400" y="4038600"/>
+            <a:ext cx="5588000" cy="768985"/>
+          </a:xfrm>
+          <a:prstGeom prst="rect">
+            <a:avLst/>
+          </a:prstGeom>
+          <a:noFill/>
+        </p:spPr>
+        <p:txBody>
+          <a:bodyPr wrap="none" lIns="0" rIns="0" tIns="0" bIns="0">
+            <a:spAutoFit/>
+          </a:bodyPr>
+          <a:lstStyle/>
+          <a:p>
+            <a:pPr>
+              <a:lnSpc>
+                <a:spcPct val="145000"/>
+              </a:lnSpc>
+              <a:spcBef>
+                <a:spcPts val="0"/>
+              </a:spcBef>
+              <a:spcAft>
+                <a:spcPts val="0"/>
+              </a:spcAft>
+              <a:defRPr sz="1300" u="none">
+                <a:solidFill>
+                  <a:srgbClr val="132333"/>
+                </a:solidFill>
+                <a:latin typeface="Hiragino Sans"/>
+              </a:defRPr>
+            </a:pPr>
+            <a:r>
+              <a:t>③ 最大約2秒・10回で0x21だけを確認</a:t>
+            </a:r>
+          </a:p>
+          <a:p>
+            <a:pPr>
+              <a:lnSpc>
+                <a:spcPct val="145000"/>
+              </a:lnSpc>
+              <a:spcBef>
+                <a:spcPts val="0"/>
+              </a:spcBef>
+              <a:spcAft>
+                <a:spcPts val="0"/>
+              </a:spcAft>
+              <a:defRPr sz="1300" u="none">
+                <a:solidFill>
+                  <a:srgbClr val="132333"/>
+                </a:solidFill>
+                <a:latin typeface="Hiragino Sans"/>
+              </a:defRPr>
+            </a:pPr>
+            <a:r>
+              <a:t>   版1〜254・手動1・TRIG 0/1まで</a:t>
+            </a:r>
+          </a:p>
+          <a:p>
+            <a:pPr>
+              <a:lnSpc>
+                <a:spcPct val="145000"/>
+              </a:lnSpc>
+              <a:spcBef>
+                <a:spcPts val="0"/>
+              </a:spcBef>
+              <a:spcAft>
+                <a:spcPts val="0"/>
+              </a:spcAft>
+              <a:defRPr sz="1300" u="none">
+                <a:solidFill>
+                  <a:srgbClr val="132333"/>
+                </a:solidFill>
+                <a:latin typeface="Hiragino Sans"/>
+              </a:defRPr>
+            </a:pPr>
+            <a:r>
+              <a:t>   読戻しが正常ならREADYへ</a:t>
+            </a:r>
+          </a:p>
+        </p:txBody>
+      </p:sp>
+      <p:sp>
+        <p:nvSpPr>
+          <p:cNvPr id="11" name="TextBox 10"/>
+          <p:cNvSpPr txBox="1"/>
+          <p:nvPr/>
+        </p:nvSpPr>
+        <p:spPr>
+          <a:xfrm>
+            <a:off x="533400" y="4914900"/>
+            <a:ext cx="5588000" cy="455930"/>
+          </a:xfrm>
+          <a:prstGeom prst="rect">
+            <a:avLst/>
+          </a:prstGeom>
+          <a:noFill/>
+        </p:spPr>
+        <p:txBody>
+          <a:bodyPr wrap="none" lIns="0" rIns="0" tIns="0" bIns="0">
+            <a:spAutoFit/>
+          </a:bodyPr>
+          <a:lstStyle/>
+          <a:p>
+            <a:pPr>
+              <a:lnSpc>
+                <a:spcPct val="145000"/>
+              </a:lnSpc>
+              <a:spcBef>
+                <a:spcPts val="0"/>
+              </a:spcBef>
+              <a:spcAft>
+                <a:spcPts val="0"/>
+              </a:spcAft>
+              <a:defRPr sz="1100" u="none">
+                <a:solidFill>
+                  <a:srgbClr val="5C7182"/>
+                </a:solidFill>
+                <a:latin typeface="Hiragino Sans"/>
+              </a:defRPr>
+            </a:pPr>
+            <a:r>
+              <a:t>起動・通信・復帰の段階を115200bpsで記録。</a:t>
+            </a:r>
+          </a:p>
+          <a:p>
+            <a:pPr>
+              <a:lnSpc>
+                <a:spcPct val="145000"/>
+              </a:lnSpc>
+              <a:spcBef>
+                <a:spcPts val="0"/>
+              </a:spcBef>
+              <a:spcAft>
+                <a:spcPts val="0"/>
+              </a:spcAft>
+              <a:defRPr sz="1100" u="none">
+                <a:solidFill>
+                  <a:srgbClr val="5C7182"/>
+                </a:solidFill>
+                <a:latin typeface="Hiragino Sans"/>
+              </a:defRPr>
+            </a:pPr>
+            <a:r>
+              <a:t>コード本文・Wi-Fi情報・キーは記録しません。</a:t>
+            </a:r>
+          </a:p>
+        </p:txBody>
+      </p:sp>
+      <p:sp>
+        <p:nvSpPr>
+          <p:cNvPr id="12" name="TextBox 11"/>
+          <p:cNvSpPr txBox="1"/>
+          <p:nvPr/>
+        </p:nvSpPr>
+        <p:spPr>
+          <a:xfrm>
+            <a:off x="6629400" y="1981200"/>
+            <a:ext cx="5029200" cy="382270"/>
+          </a:xfrm>
+          <a:prstGeom prst="rect">
+            <a:avLst/>
+          </a:prstGeom>
+          <a:noFill/>
+        </p:spPr>
+        <p:txBody>
+          <a:bodyPr wrap="none" lIns="0" rIns="0" tIns="0" bIns="0">
+            <a:spAutoFit/>
+          </a:bodyPr>
+          <a:lstStyle/>
+          <a:p>
+            <a:pPr>
+              <a:lnSpc>
+                <a:spcPct val="145000"/>
+              </a:lnSpc>
+              <a:spcBef>
+                <a:spcPts val="0"/>
+              </a:spcBef>
+              <a:spcAft>
+                <a:spcPts val="0"/>
+              </a:spcAft>
+              <a:defRPr sz="1800" u="none">
+                <a:solidFill>
+                  <a:srgbClr val="356FF0"/>
+                </a:solidFill>
+                <a:latin typeface="Hiragino Sans"/>
+              </a:defRPr>
+            </a:pPr>
+            <a:r>
+              <a:t>確認中と停止時の表示</a:t>
+            </a:r>
+          </a:p>
+        </p:txBody>
+      </p:sp>
+      <p:sp>
+        <p:nvSpPr>
+          <p:cNvPr id="13" name="TextBox 12"/>
+          <p:cNvSpPr txBox="1"/>
+          <p:nvPr/>
+        </p:nvSpPr>
+        <p:spPr>
+          <a:xfrm>
+            <a:off x="6629400" y="2438400"/>
+            <a:ext cx="5029200" cy="1247775"/>
+          </a:xfrm>
+          <a:prstGeom prst="rect">
+            <a:avLst/>
+          </a:prstGeom>
+          <a:noFill/>
+        </p:spPr>
+        <p:txBody>
+          <a:bodyPr wrap="none" lIns="0" rIns="0" tIns="0" bIns="0">
+            <a:spAutoFit/>
+          </a:bodyPr>
+          <a:lstStyle/>
+          <a:p>
+            <a:pPr>
+              <a:lnSpc>
+                <a:spcPct val="145000"/>
+              </a:lnSpc>
+              <a:spcBef>
+                <a:spcPts val="0"/>
+              </a:spcBef>
+              <a:spcAft>
+                <a:spcPts val="0"/>
+              </a:spcAft>
+              <a:defRPr sz="1300" u="none">
+                <a:solidFill>
+                  <a:srgbClr val="132333"/>
+                </a:solidFill>
+                <a:latin typeface="Hiragino Sans"/>
+              </a:defRPr>
+            </a:pPr>
+            <a:r>
+              <a:t>STARTING / READER RESUME：復帰確認中</a:t>
+            </a:r>
+          </a:p>
+          <a:p>
+            <a:pPr>
+              <a:lnSpc>
+                <a:spcPct val="145000"/>
+              </a:lnSpc>
+              <a:spcBef>
+                <a:spcPts val="0"/>
+              </a:spcBef>
+              <a:spcAft>
+                <a:spcPts val="0"/>
+              </a:spcAft>
+              <a:defRPr sz="1300" u="none">
+                <a:solidFill>
+                  <a:srgbClr val="132333"/>
+                </a:solidFill>
+                <a:latin typeface="Hiragino Sans"/>
+              </a:defRPr>
+            </a:pPr>
+            <a:r>
+              <a:t>ERROR / RECOVERY HOLD：復帰未確認</a:t>
+            </a:r>
+          </a:p>
+          <a:p>
+            <a:pPr>
+              <a:lnSpc>
+                <a:spcPct val="145000"/>
+              </a:lnSpc>
+              <a:spcBef>
+                <a:spcPts val="0"/>
+              </a:spcBef>
+              <a:spcAft>
+                <a:spcPts val="0"/>
+              </a:spcAft>
+              <a:defRPr sz="1300" u="none">
+                <a:solidFill>
+                  <a:srgbClr val="132333"/>
+                </a:solidFill>
+                <a:latin typeface="Hiragino Sans"/>
+              </a:defRPr>
+            </a:pPr>
+            <a:r>
+              <a:t>READER STORAGE：復帰の記録保存に失敗</a:t>
+            </a:r>
+          </a:p>
+          <a:p>
+            <a:pPr>
+              <a:lnSpc>
+                <a:spcPct val="145000"/>
+              </a:lnSpc>
+              <a:spcBef>
+                <a:spcPts val="0"/>
+              </a:spcBef>
+              <a:spcAft>
+                <a:spcPts val="0"/>
+              </a:spcAft>
+              <a:defRPr sz="1300" u="none">
+                <a:solidFill>
+                  <a:srgbClr val="132333"/>
+                </a:solidFill>
+                <a:latin typeface="Hiragino Sans"/>
+              </a:defRPr>
+            </a:pPr>
+            <a:r>
+              <a:t>READER POWER / BUS / I2C：給電・通信</a:t>
+            </a:r>
+          </a:p>
+          <a:p>
+            <a:pPr>
+              <a:lnSpc>
+                <a:spcPct val="145000"/>
+              </a:lnSpc>
+              <a:spcBef>
+                <a:spcPts val="0"/>
+              </a:spcBef>
+              <a:spcAft>
+                <a:spcPts val="0"/>
+              </a:spcAft>
+              <a:defRPr sz="1300" u="none">
+                <a:solidFill>
+                  <a:srgbClr val="132333"/>
+                </a:solidFill>
+                <a:latin typeface="Hiragino Sans"/>
+              </a:defRPr>
+            </a:pPr>
+            <a:r>
+              <a:t>READER CONFIG：版・設定・TRIG読戻し</a:t>
+            </a:r>
+          </a:p>
+        </p:txBody>
+      </p:sp>
+      <p:sp>
+        <p:nvSpPr>
+          <p:cNvPr id="14" name="TextBox 13"/>
+          <p:cNvSpPr txBox="1"/>
+          <p:nvPr/>
+        </p:nvSpPr>
+        <p:spPr>
+          <a:xfrm>
+            <a:off x="6629400" y="3810000"/>
+            <a:ext cx="5029200" cy="1376680"/>
+          </a:xfrm>
+          <a:prstGeom prst="rect">
+            <a:avLst/>
+          </a:prstGeom>
+          <a:noFill/>
+        </p:spPr>
+        <p:txBody>
+          <a:bodyPr wrap="none" lIns="0" rIns="0" tIns="0" bIns="0">
+            <a:spAutoFit/>
+          </a:bodyPr>
+          <a:lstStyle/>
+          <a:p>
+            <a:pPr>
+              <a:lnSpc>
+                <a:spcPct val="145000"/>
+              </a:lnSpc>
+              <a:spcBef>
+                <a:spcPts val="0"/>
+              </a:spcBef>
+              <a:spcAft>
+                <a:spcPts val="0"/>
+              </a:spcAft>
+              <a:defRPr sz="1200" u="none">
+                <a:solidFill>
+                  <a:srgbClr val="5C7182"/>
+                </a:solidFill>
+                <a:latin typeface="Hiragino Sans"/>
+              </a:defRPr>
+            </a:pPr>
+            <a:r>
+              <a:t>復帰命令の前に確認待ちを端末へ保存。</a:t>
+            </a:r>
+          </a:p>
+          <a:p>
+            <a:pPr>
+              <a:lnSpc>
+                <a:spcPct val="145000"/>
+              </a:lnSpc>
+              <a:spcBef>
+                <a:spcPts val="0"/>
+              </a:spcBef>
+              <a:spcAft>
+                <a:spcPts val="0"/>
+              </a:spcAft>
+              <a:defRPr sz="1200" u="none">
+                <a:solidFill>
+                  <a:srgbClr val="5C7182"/>
+                </a:solidFill>
+                <a:latin typeface="Hiragino Sans"/>
+              </a:defRPr>
+            </a:pPr>
+            <a:r>
+              <a:t>失敗や本体再起動後も0x54を再確認せず、</a:t>
+            </a:r>
+          </a:p>
+          <a:p>
+            <a:pPr>
+              <a:lnSpc>
+                <a:spcPct val="145000"/>
+              </a:lnSpc>
+              <a:spcBef>
+                <a:spcPts val="0"/>
+              </a:spcBef>
+              <a:spcAft>
+                <a:spcPts val="0"/>
+              </a:spcAft>
+              <a:defRPr sz="1200" u="none">
+                <a:solidFill>
+                  <a:srgbClr val="5C7182"/>
+                </a:solidFill>
+                <a:latin typeface="Hiragino Sans"/>
+              </a:defRPr>
+            </a:pPr>
+            <a:r>
+              <a:t>命令を再送しません。正常0x21の設定まで</a:t>
+            </a:r>
+          </a:p>
+          <a:p>
+            <a:pPr>
+              <a:lnSpc>
+                <a:spcPct val="145000"/>
+              </a:lnSpc>
+              <a:spcBef>
+                <a:spcPts val="0"/>
+              </a:spcBef>
+              <a:spcAft>
+                <a:spcPts val="0"/>
+              </a:spcAft>
+              <a:defRPr sz="1200" u="none">
+                <a:solidFill>
+                  <a:srgbClr val="5C7182"/>
+                </a:solidFill>
+                <a:latin typeface="Hiragino Sans"/>
+              </a:defRPr>
+            </a:pPr>
+            <a:r>
+              <a:t>確認できた場合だけ記録を解除します。</a:t>
+            </a:r>
+          </a:p>
+          <a:p>
+            <a:pPr>
+              <a:lnSpc>
+                <a:spcPct val="145000"/>
+              </a:lnSpc>
+              <a:spcBef>
+                <a:spcPts val="0"/>
+              </a:spcBef>
+              <a:spcAft>
+                <a:spcPts val="0"/>
+              </a:spcAft>
+              <a:defRPr sz="1200" u="none">
+                <a:solidFill>
+                  <a:srgbClr val="5C7182"/>
+                </a:solidFill>
+                <a:latin typeface="Hiragino Sans"/>
+              </a:defRPr>
+            </a:pPr>
+            <a:r>
+              <a:t>Aボタンで再試行せず、ログを確認します。</a:t>
+            </a:r>
+          </a:p>
+          <a:p>
+            <a:pPr>
+              <a:lnSpc>
+                <a:spcPct val="145000"/>
+              </a:lnSpc>
+              <a:spcBef>
+                <a:spcPts val="0"/>
+              </a:spcBef>
+              <a:spcAft>
+                <a:spcPts val="0"/>
+              </a:spcAft>
+              <a:defRPr sz="1200" u="none">
+                <a:solidFill>
+                  <a:srgbClr val="5C7182"/>
+                </a:solidFill>
+                <a:latin typeface="Hiragino Sans"/>
+              </a:defRPr>
+            </a:pPr>
+            <a:r>
+              <a:t>未送信イベントは保持。全消去しないでください。</a:t>
+            </a:r>
+          </a:p>
+        </p:txBody>
+      </p:sp>
+      <p:sp>
+        <p:nvSpPr>
+          <p:cNvPr id="15" name="TextBox 14"/>
+          <p:cNvSpPr txBox="1"/>
+          <p:nvPr/>
+        </p:nvSpPr>
+        <p:spPr>
+          <a:xfrm>
+            <a:off x="533400" y="5600700"/>
+            <a:ext cx="11125200" cy="492759"/>
+          </a:xfrm>
+          <a:prstGeom prst="rect">
+            <a:avLst/>
+          </a:prstGeom>
+          <a:noFill/>
+        </p:spPr>
+        <p:txBody>
+          <a:bodyPr wrap="none" lIns="0" rIns="0" tIns="0" bIns="0">
+            <a:spAutoFit/>
+          </a:bodyPr>
+          <a:lstStyle/>
+          <a:p>
+            <a:pPr>
+              <a:lnSpc>
+                <a:spcPct val="145000"/>
+              </a:lnSpc>
+              <a:spcBef>
+                <a:spcPts val="0"/>
+              </a:spcBef>
+              <a:spcAft>
+                <a:spcPts val="0"/>
+              </a:spcAft>
+              <a:defRPr sz="1200" u="none">
+                <a:solidFill>
+                  <a:srgbClr val="132333"/>
+                </a:solidFill>
+                <a:latin typeface="Hiragino Sans"/>
+              </a:defRPr>
+            </a:pPr>
+            <a:r>
+              <a:t>ブート復帰は実機未検証です。Unit起動時の不調を対象とし、スキャン中の異常とは区別します。</a:t>
+            </a:r>
+          </a:p>
+          <a:p>
+            <a:pPr>
+              <a:lnSpc>
+                <a:spcPct val="145000"/>
+              </a:lnSpc>
+              <a:spcBef>
+                <a:spcPts val="0"/>
+              </a:spcBef>
+              <a:spcAft>
+                <a:spcPts val="0"/>
+              </a:spcAft>
+              <a:defRPr sz="1200" u="none">
+                <a:solidFill>
+                  <a:srgbClr val="132333"/>
+                </a:solidFill>
+                <a:latin typeface="Hiragino Sans"/>
+              </a:defRPr>
+            </a:pPr>
+            <a:r>
+              <a:t>電源原因の確定や再発防止の実証とは扱わず、READY・実読取り・Scans保存を別々に確認します。</a:t>
+            </a:r>
+          </a:p>
+        </p:txBody>
+      </p:sp>
+      <p:sp>
+        <p:nvSpPr>
+          <p:cNvPr id="16" name="TextBox 15"/>
+          <p:cNvSpPr txBox="1"/>
+          <p:nvPr/>
+        </p:nvSpPr>
+        <p:spPr>
+          <a:xfrm>
+            <a:off x="533400" y="6553200"/>
+            <a:ext cx="3556000" cy="234950"/>
+          </a:xfrm>
+          <a:prstGeom prst="rect">
+            <a:avLst/>
+          </a:prstGeom>
+          <a:noFill/>
+        </p:spPr>
+        <p:txBody>
+          <a:bodyPr wrap="none" lIns="0" rIns="0" tIns="0" bIns="0">
+            <a:spAutoFit/>
+          </a:bodyPr>
+          <a:lstStyle/>
+          <a:p>
+            <a:pPr>
+              <a:lnSpc>
+                <a:spcPct val="145000"/>
+              </a:lnSpc>
+              <a:spcBef>
+                <a:spcPts val="0"/>
+              </a:spcBef>
+              <a:spcAft>
+                <a:spcPts val="0"/>
+              </a:spcAft>
+              <a:defRPr sz="1000" u="none">
+                <a:solidFill>
+                  <a:srgbClr val="5C7182"/>
+                </a:solidFill>
+                <a:latin typeface="Hiragino Sans"/>
+              </a:defRPr>
+            </a:pPr>
+            <a:r>
+              <a:t>M5Stack 在庫管理システム</a:t>
+            </a:r>
+          </a:p>
+        </p:txBody>
+      </p:sp>
+      <p:sp>
+        <p:nvSpPr>
+          <p:cNvPr id="17" name="TextBox 16"/>
+          <p:cNvSpPr txBox="1"/>
+          <p:nvPr/>
+        </p:nvSpPr>
+        <p:spPr>
+          <a:xfrm>
+            <a:off x="4635500" y="6553200"/>
+            <a:ext cx="5461000" cy="234950"/>
+          </a:xfrm>
+          <a:prstGeom prst="rect">
+            <a:avLst/>
+          </a:prstGeom>
+          <a:noFill/>
+        </p:spPr>
+        <p:txBody>
+          <a:bodyPr wrap="none" lIns="0" rIns="0" tIns="0" bIns="0">
+            <a:spAutoFit/>
+          </a:bodyPr>
+          <a:lstStyle/>
+          <a:p>
+            <a:pPr>
+              <a:lnSpc>
+                <a:spcPct val="145000"/>
+              </a:lnSpc>
+              <a:spcBef>
+                <a:spcPts val="0"/>
+              </a:spcBef>
+              <a:spcAft>
+                <a:spcPts val="0"/>
+              </a:spcAft>
+              <a:defRPr sz="1000" u="none">
+                <a:solidFill>
+                  <a:srgbClr val="5C7182"/>
+                </a:solidFill>
+                <a:latin typeface="Hiragino Sans"/>
+              </a:defRPr>
+            </a:pPr>
+            <a:r>
+              <a:t>© 2026 K Visualization Studio</a:t>
+            </a:r>
+          </a:p>
+        </p:txBody>
+      </p:sp>
+      <p:sp>
+        <p:nvSpPr>
+          <p:cNvPr id="18" name="TextBox 17"/>
+          <p:cNvSpPr txBox="1"/>
+          <p:nvPr/>
+        </p:nvSpPr>
+        <p:spPr>
+          <a:xfrm>
+            <a:off x="11150600" y="6553200"/>
+            <a:ext cx="508000" cy="234950"/>
+          </a:xfrm>
+          <a:prstGeom prst="rect">
+            <a:avLst/>
+          </a:prstGeom>
+          <a:noFill/>
+        </p:spPr>
+        <p:txBody>
+          <a:bodyPr wrap="none" lIns="0" rIns="0" tIns="0" bIns="0">
+            <a:spAutoFit/>
+          </a:bodyPr>
+          <a:lstStyle/>
+          <a:p>
+            <a:pPr>
+              <a:lnSpc>
+                <a:spcPct val="145000"/>
+              </a:lnSpc>
+              <a:spcBef>
+                <a:spcPts val="0"/>
+              </a:spcBef>
+              <a:spcAft>
+                <a:spcPts val="0"/>
+              </a:spcAft>
+              <a:defRPr sz="1000" u="none">
+                <a:solidFill>
+                  <a:srgbClr val="5C7182"/>
+                </a:solidFill>
+                <a:latin typeface="Hiragino Sans"/>
+              </a:defRPr>
+            </a:pPr>
+            <a:r>
+              <a:t>23</a:t>
+            </a:r>
+          </a:p>
+        </p:txBody>
+      </p:sp>
+    </p:spTree>
+  </p:cSld>
+  <p:clrMapOvr>
+    <a:masterClrMapping/>
+  </p:clrMapOvr>
+</p:sld>
+</file>
+
 <file path=ppt/slides/slide3.xml><?xml version="1.0" encoding="utf-8"?>
 <p:sld xmlns:p="http://schemas.openxmlformats.org/presentationml/2006/main">
   <p:cSld>

</xml_diff>

<commit_message>
Restore Unit QRCode from boot mode with one guarded request (#4)
* Recover Unit QRCode startup with a single guarded boot return

* Keep setup and validation links usable in standalone Arduino downloads

---------

Co-authored-by: TikTak007 <TikTak007@users.noreply.github.com>
</commit_message>
<xml_diff>
--- a/docs/M5Stack_Inventory_Guide.pptx
+++ b/docs/M5Stack_Inventory_Guide.pptx
@@ -30,6 +30,7 @@
     <p:sldId xmlns:r="http://schemas.openxmlformats.org/officeDocument/2006/relationships" id="275" r:id="R6d190955e3bc4720"/>
     <p:sldId xmlns:r="http://schemas.openxmlformats.org/officeDocument/2006/relationships" id="276" r:id="Rfbe8211efeb44a70"/>
     <p:sldId xmlns:r="http://schemas.openxmlformats.org/officeDocument/2006/relationships" id="277" r:id="Rd6ef078fbf5e48c0"/>
+    <p:sldId xmlns:ns0="http://schemas.openxmlformats.org/officeDocument/2006/relationships" id="278" ns0:id="rId28"/>
   </p:sldIdLst>
   <p:sldSz cx="12192000" cy="6858000"/>
   <p:notesSz cx="6858000" cy="9144000"/>
@@ -27468,6 +27469,1167 @@
 </p:sld>
 </file>
 
+<file path=ppt/slides/slide23.xml><?xml version="1.0" encoding="utf-8"?>
+<p:sld xmlns:a="http://schemas.openxmlformats.org/drawingml/2006/main" xmlns:p="http://schemas.openxmlformats.org/presentationml/2006/main" xmlns:r="http://schemas.openxmlformats.org/officeDocument/2006/relationships">
+  <p:cSld>
+    <p:bg>
+      <p:bgPr>
+        <a:solidFill>
+          <a:srgbClr val="F4F7FA"/>
+        </a:solidFill>
+        <a:effectLst/>
+      </p:bgPr>
+    </p:bg>
+    <p:spTree>
+      <p:nvGrpSpPr>
+        <p:cNvPr id="1" name=""/>
+        <p:cNvGrpSpPr/>
+        <p:nvPr/>
+      </p:nvGrpSpPr>
+      <p:grpSpPr/>
+      <p:sp>
+        <p:nvSpPr>
+          <p:cNvPr id="2" name="Rectangle 1"/>
+          <p:cNvSpPr/>
+          <p:nvPr/>
+        </p:nvSpPr>
+        <p:spPr>
+          <a:xfrm>
+            <a:off x="0" y="0"/>
+            <a:ext cx="152400" cy="6858000"/>
+          </a:xfrm>
+          <a:prstGeom prst="rect">
+            <a:avLst/>
+          </a:prstGeom>
+          <a:solidFill>
+            <a:srgbClr val="00B8E6"/>
+          </a:solidFill>
+          <a:ln>
+            <a:noFill/>
+          </a:ln>
+        </p:spPr>
+        <p:style>
+          <a:lnRef idx="1">
+            <a:schemeClr val="accent1"/>
+          </a:lnRef>
+          <a:fillRef idx="3">
+            <a:schemeClr val="accent1"/>
+          </a:fillRef>
+          <a:effectRef idx="2">
+            <a:schemeClr val="accent1"/>
+          </a:effectRef>
+          <a:fontRef idx="minor">
+            <a:schemeClr val="lt1"/>
+          </a:fontRef>
+        </p:style>
+        <p:txBody>
+          <a:bodyPr rtlCol="0" anchor="ctr"/>
+          <a:lstStyle/>
+          <a:p>
+            <a:pPr algn="ctr"/>
+          </a:p>
+        </p:txBody>
+      </p:sp>
+      <p:sp>
+        <p:nvSpPr>
+          <p:cNvPr id="3" name="Rectangle 2"/>
+          <p:cNvSpPr/>
+          <p:nvPr/>
+        </p:nvSpPr>
+        <p:spPr>
+          <a:xfrm>
+            <a:off x="533400" y="6350000"/>
+            <a:ext cx="11125200" cy="12700"/>
+          </a:xfrm>
+          <a:prstGeom prst="rect">
+            <a:avLst/>
+          </a:prstGeom>
+          <a:solidFill>
+            <a:srgbClr val="D9E3EA"/>
+          </a:solidFill>
+          <a:ln>
+            <a:noFill/>
+          </a:ln>
+        </p:spPr>
+        <p:style>
+          <a:lnRef idx="1">
+            <a:schemeClr val="accent1"/>
+          </a:lnRef>
+          <a:fillRef idx="3">
+            <a:schemeClr val="accent1"/>
+          </a:fillRef>
+          <a:effectRef idx="2">
+            <a:schemeClr val="accent1"/>
+          </a:effectRef>
+          <a:fontRef idx="minor">
+            <a:schemeClr val="lt1"/>
+          </a:fontRef>
+        </p:style>
+        <p:txBody>
+          <a:bodyPr rtlCol="0" anchor="ctr"/>
+          <a:lstStyle/>
+          <a:p>
+            <a:pPr algn="ctr"/>
+          </a:p>
+        </p:txBody>
+      </p:sp>
+      <p:sp>
+        <p:nvSpPr>
+          <p:cNvPr id="4" name="TextBox 3"/>
+          <p:cNvSpPr txBox="1"/>
+          <p:nvPr/>
+        </p:nvSpPr>
+        <p:spPr>
+          <a:xfrm>
+            <a:off x="533400" y="304800"/>
+            <a:ext cx="11125200" cy="345440"/>
+          </a:xfrm>
+          <a:prstGeom prst="rect">
+            <a:avLst/>
+          </a:prstGeom>
+          <a:noFill/>
+        </p:spPr>
+        <p:txBody>
+          <a:bodyPr wrap="none" lIns="0" rIns="0" tIns="0" bIns="0">
+            <a:spAutoFit/>
+          </a:bodyPr>
+          <a:lstStyle/>
+          <a:p>
+            <a:pPr>
+              <a:lnSpc>
+                <a:spcPct val="145000"/>
+              </a:lnSpc>
+              <a:spcBef>
+                <a:spcPts val="0"/>
+              </a:spcBef>
+              <a:spcAft>
+                <a:spcPts val="0"/>
+              </a:spcAft>
+              <a:defRPr sz="1600" u="none">
+                <a:solidFill>
+                  <a:srgbClr val="356FF0"/>
+                </a:solidFill>
+                <a:latin typeface="Hiragino Sans"/>
+              </a:defRPr>
+            </a:pPr>
+            <a:r>
+              <a:t>付録  StickS3 / Unit QRCode</a:t>
+            </a:r>
+          </a:p>
+        </p:txBody>
+      </p:sp>
+      <p:sp>
+        <p:nvSpPr>
+          <p:cNvPr id="5" name="TextBox 4"/>
+          <p:cNvSpPr txBox="1"/>
+          <p:nvPr/>
+        </p:nvSpPr>
+        <p:spPr>
+          <a:xfrm>
+            <a:off x="533400" y="762000"/>
+            <a:ext cx="11125200" cy="566420"/>
+          </a:xfrm>
+          <a:prstGeom prst="rect">
+            <a:avLst/>
+          </a:prstGeom>
+          <a:noFill/>
+        </p:spPr>
+        <p:txBody>
+          <a:bodyPr wrap="none" lIns="0" rIns="0" tIns="0" bIns="0">
+            <a:spAutoFit/>
+          </a:bodyPr>
+          <a:lstStyle/>
+          <a:p>
+            <a:pPr>
+              <a:lnSpc>
+                <a:spcPct val="145000"/>
+              </a:lnSpc>
+              <a:spcBef>
+                <a:spcPts val="0"/>
+              </a:spcBef>
+              <a:spcAft>
+                <a:spcPts val="0"/>
+              </a:spcAft>
+              <a:defRPr sz="2800" u="none">
+                <a:solidFill>
+                  <a:srgbClr val="132333"/>
+                </a:solidFill>
+                <a:latin typeface="Hiragino Sans"/>
+              </a:defRPr>
+            </a:pPr>
+            <a:r>
+              <a:t>StickS3の起動確認と切り分け</a:t>
+            </a:r>
+          </a:p>
+        </p:txBody>
+      </p:sp>
+      <p:sp>
+        <p:nvSpPr>
+          <p:cNvPr id="6" name="TextBox 5"/>
+          <p:cNvSpPr txBox="1"/>
+          <p:nvPr/>
+        </p:nvSpPr>
+        <p:spPr>
+          <a:xfrm>
+            <a:off x="533400" y="1409700"/>
+            <a:ext cx="11125200" cy="290195"/>
+          </a:xfrm>
+          <a:prstGeom prst="rect">
+            <a:avLst/>
+          </a:prstGeom>
+          <a:noFill/>
+        </p:spPr>
+        <p:txBody>
+          <a:bodyPr wrap="none" lIns="0" rIns="0" tIns="0" bIns="0">
+            <a:spAutoFit/>
+          </a:bodyPr>
+          <a:lstStyle/>
+          <a:p>
+            <a:pPr>
+              <a:lnSpc>
+                <a:spcPct val="145000"/>
+              </a:lnSpc>
+              <a:spcBef>
+                <a:spcPts val="0"/>
+              </a:spcBef>
+              <a:spcAft>
+                <a:spcPts val="0"/>
+              </a:spcAft>
+              <a:defRPr sz="1300" u="none">
+                <a:solidFill>
+                  <a:srgbClr val="5C7182"/>
+                </a:solidFill>
+                <a:latin typeface="Hiragino Sans"/>
+              </a:defRPr>
+            </a:pPr>
+            <a:r>
+              <a:t>Unit起動時のブートモードから、電源を切り替えず通常の読取りへ戻すための機能です。</a:t>
+            </a:r>
+          </a:p>
+        </p:txBody>
+      </p:sp>
+      <p:sp>
+        <p:nvSpPr>
+          <p:cNvPr id="7" name="TextBox 6"/>
+          <p:cNvSpPr txBox="1"/>
+          <p:nvPr/>
+        </p:nvSpPr>
+        <p:spPr>
+          <a:xfrm>
+            <a:off x="533400" y="1981200"/>
+            <a:ext cx="5588000" cy="382270"/>
+          </a:xfrm>
+          <a:prstGeom prst="rect">
+            <a:avLst/>
+          </a:prstGeom>
+          <a:noFill/>
+        </p:spPr>
+        <p:txBody>
+          <a:bodyPr wrap="none" lIns="0" rIns="0" tIns="0" bIns="0">
+            <a:spAutoFit/>
+          </a:bodyPr>
+          <a:lstStyle/>
+          <a:p>
+            <a:pPr>
+              <a:lnSpc>
+                <a:spcPct val="145000"/>
+              </a:lnSpc>
+              <a:spcBef>
+                <a:spcPts val="0"/>
+              </a:spcBef>
+              <a:spcAft>
+                <a:spcPts val="0"/>
+              </a:spcAft>
+              <a:defRPr sz="1800" u="none">
+                <a:solidFill>
+                  <a:srgbClr val="356FF0"/>
+                </a:solidFill>
+                <a:latin typeface="Hiragino Sans"/>
+              </a:defRPr>
+            </a:pPr>
+            <a:r>
+              <a:t>READYになるまで</a:t>
+            </a:r>
+          </a:p>
+        </p:txBody>
+      </p:sp>
+      <p:sp>
+        <p:nvSpPr>
+          <p:cNvPr id="8" name="TextBox 7"/>
+          <p:cNvSpPr txBox="1"/>
+          <p:nvPr/>
+        </p:nvSpPr>
+        <p:spPr>
+          <a:xfrm>
+            <a:off x="533400" y="2438400"/>
+            <a:ext cx="5588000" cy="768985"/>
+          </a:xfrm>
+          <a:prstGeom prst="rect">
+            <a:avLst/>
+          </a:prstGeom>
+          <a:noFill/>
+        </p:spPr>
+        <p:txBody>
+          <a:bodyPr wrap="none" lIns="0" rIns="0" tIns="0" bIns="0">
+            <a:spAutoFit/>
+          </a:bodyPr>
+          <a:lstStyle/>
+          <a:p>
+            <a:pPr>
+              <a:lnSpc>
+                <a:spcPct val="145000"/>
+              </a:lnSpc>
+              <a:spcBef>
+                <a:spcPts val="0"/>
+              </a:spcBef>
+              <a:spcAft>
+                <a:spcPts val="0"/>
+              </a:spcAft>
+              <a:defRPr sz="1300" u="none">
+                <a:solidFill>
+                  <a:srgbClr val="132333"/>
+                </a:solidFill>
+                <a:latin typeface="Hiragino Sans"/>
+              </a:defRPr>
+            </a:pPr>
+            <a:r>
+              <a:t>① 初期化中もIRを消灯（GPIO46 LOW）</a:t>
+            </a:r>
+          </a:p>
+          <a:p>
+            <a:pPr>
+              <a:lnSpc>
+                <a:spcPct val="145000"/>
+              </a:lnSpc>
+              <a:spcBef>
+                <a:spcPts val="0"/>
+              </a:spcBef>
+              <a:spcAft>
+                <a:spcPts val="0"/>
+              </a:spcAft>
+              <a:defRPr sz="1300" u="none">
+                <a:solidFill>
+                  <a:srgbClr val="132333"/>
+                </a:solidFill>
+                <a:latin typeface="Hiragino Sans"/>
+              </a:defRPr>
+            </a:pPr>
+            <a:r>
+              <a:t>   最初の給電後800msは通信せず待つ</a:t>
+            </a:r>
+          </a:p>
+          <a:p>
+            <a:pPr>
+              <a:lnSpc>
+                <a:spcPct val="145000"/>
+              </a:lnSpc>
+              <a:spcBef>
+                <a:spcPts val="0"/>
+              </a:spcBef>
+              <a:spcAft>
+                <a:spcPts val="0"/>
+              </a:spcAft>
+              <a:defRPr sz="1300" u="none">
+                <a:solidFill>
+                  <a:srgbClr val="132333"/>
+                </a:solidFill>
+                <a:latin typeface="Hiragino Sans"/>
+              </a:defRPr>
+            </a:pPr>
+            <a:r>
+              <a:t>   正常0x21の設定を確認してREADYへ</a:t>
+            </a:r>
+          </a:p>
+        </p:txBody>
+      </p:sp>
+      <p:sp>
+        <p:nvSpPr>
+          <p:cNvPr id="9" name="TextBox 8"/>
+          <p:cNvSpPr txBox="1"/>
+          <p:nvPr/>
+        </p:nvSpPr>
+        <p:spPr>
+          <a:xfrm>
+            <a:off x="533400" y="3238500"/>
+            <a:ext cx="5588000" cy="768985"/>
+          </a:xfrm>
+          <a:prstGeom prst="rect">
+            <a:avLst/>
+          </a:prstGeom>
+          <a:noFill/>
+        </p:spPr>
+        <p:txBody>
+          <a:bodyPr wrap="none" lIns="0" rIns="0" tIns="0" bIns="0">
+            <a:spAutoFit/>
+          </a:bodyPr>
+          <a:lstStyle/>
+          <a:p>
+            <a:pPr>
+              <a:lnSpc>
+                <a:spcPct val="145000"/>
+              </a:lnSpc>
+              <a:spcBef>
+                <a:spcPts val="0"/>
+              </a:spcBef>
+              <a:spcAft>
+                <a:spcPts val="0"/>
+              </a:spcAft>
+              <a:defRPr sz="1300" u="none">
+                <a:solidFill>
+                  <a:srgbClr val="132333"/>
+                </a:solidFill>
+                <a:latin typeface="Hiragino Sans"/>
+              </a:defRPr>
+            </a:pPr>
+            <a:r>
+              <a:t>② ブート0x54だけが応答した場合</a:t>
+            </a:r>
+          </a:p>
+          <a:p>
+            <a:pPr>
+              <a:lnSpc>
+                <a:spcPct val="145000"/>
+              </a:lnSpc>
+              <a:spcBef>
+                <a:spcPts val="0"/>
+              </a:spcBef>
+              <a:spcAft>
+                <a:spcPts val="0"/>
+              </a:spcAft>
+              <a:defRPr sz="1300" u="none">
+                <a:solidFill>
+                  <a:srgbClr val="132333"/>
+                </a:solidFill>
+                <a:latin typeface="Hiragino Sans"/>
+              </a:defRPr>
+            </a:pPr>
+            <a:r>
+              <a:t>   復帰命令0x77を一度だけ送る</a:t>
+            </a:r>
+          </a:p>
+          <a:p>
+            <a:pPr>
+              <a:lnSpc>
+                <a:spcPct val="145000"/>
+              </a:lnSpc>
+              <a:spcBef>
+                <a:spcPts val="0"/>
+              </a:spcBef>
+              <a:spcAft>
+                <a:spcPts val="0"/>
+              </a:spcAft>
+              <a:defRPr sz="1300" u="none">
+                <a:solidFill>
+                  <a:srgbClr val="132333"/>
+                </a:solidFill>
+                <a:latin typeface="Hiragino Sans"/>
+              </a:defRPr>
+            </a:pPr>
+            <a:r>
+              <a:t>   電源は切り替えない</a:t>
+            </a:r>
+          </a:p>
+        </p:txBody>
+      </p:sp>
+      <p:sp>
+        <p:nvSpPr>
+          <p:cNvPr id="10" name="TextBox 9"/>
+          <p:cNvSpPr txBox="1"/>
+          <p:nvPr/>
+        </p:nvSpPr>
+        <p:spPr>
+          <a:xfrm>
+            <a:off x="533400" y="4038600"/>
+            <a:ext cx="5588000" cy="768985"/>
+          </a:xfrm>
+          <a:prstGeom prst="rect">
+            <a:avLst/>
+          </a:prstGeom>
+          <a:noFill/>
+        </p:spPr>
+        <p:txBody>
+          <a:bodyPr wrap="none" lIns="0" rIns="0" tIns="0" bIns="0">
+            <a:spAutoFit/>
+          </a:bodyPr>
+          <a:lstStyle/>
+          <a:p>
+            <a:pPr>
+              <a:lnSpc>
+                <a:spcPct val="145000"/>
+              </a:lnSpc>
+              <a:spcBef>
+                <a:spcPts val="0"/>
+              </a:spcBef>
+              <a:spcAft>
+                <a:spcPts val="0"/>
+              </a:spcAft>
+              <a:defRPr sz="1300" u="none">
+                <a:solidFill>
+                  <a:srgbClr val="132333"/>
+                </a:solidFill>
+                <a:latin typeface="Hiragino Sans"/>
+              </a:defRPr>
+            </a:pPr>
+            <a:r>
+              <a:t>③ 最大約2秒・10回で0x21だけを確認</a:t>
+            </a:r>
+          </a:p>
+          <a:p>
+            <a:pPr>
+              <a:lnSpc>
+                <a:spcPct val="145000"/>
+              </a:lnSpc>
+              <a:spcBef>
+                <a:spcPts val="0"/>
+              </a:spcBef>
+              <a:spcAft>
+                <a:spcPts val="0"/>
+              </a:spcAft>
+              <a:defRPr sz="1300" u="none">
+                <a:solidFill>
+                  <a:srgbClr val="132333"/>
+                </a:solidFill>
+                <a:latin typeface="Hiragino Sans"/>
+              </a:defRPr>
+            </a:pPr>
+            <a:r>
+              <a:t>   版1〜254・手動1・TRIG 0/1まで</a:t>
+            </a:r>
+          </a:p>
+          <a:p>
+            <a:pPr>
+              <a:lnSpc>
+                <a:spcPct val="145000"/>
+              </a:lnSpc>
+              <a:spcBef>
+                <a:spcPts val="0"/>
+              </a:spcBef>
+              <a:spcAft>
+                <a:spcPts val="0"/>
+              </a:spcAft>
+              <a:defRPr sz="1300" u="none">
+                <a:solidFill>
+                  <a:srgbClr val="132333"/>
+                </a:solidFill>
+                <a:latin typeface="Hiragino Sans"/>
+              </a:defRPr>
+            </a:pPr>
+            <a:r>
+              <a:t>   読戻しが正常ならREADYへ</a:t>
+            </a:r>
+          </a:p>
+        </p:txBody>
+      </p:sp>
+      <p:sp>
+        <p:nvSpPr>
+          <p:cNvPr id="11" name="TextBox 10"/>
+          <p:cNvSpPr txBox="1"/>
+          <p:nvPr/>
+        </p:nvSpPr>
+        <p:spPr>
+          <a:xfrm>
+            <a:off x="533400" y="4914900"/>
+            <a:ext cx="5588000" cy="455930"/>
+          </a:xfrm>
+          <a:prstGeom prst="rect">
+            <a:avLst/>
+          </a:prstGeom>
+          <a:noFill/>
+        </p:spPr>
+        <p:txBody>
+          <a:bodyPr wrap="none" lIns="0" rIns="0" tIns="0" bIns="0">
+            <a:spAutoFit/>
+          </a:bodyPr>
+          <a:lstStyle/>
+          <a:p>
+            <a:pPr>
+              <a:lnSpc>
+                <a:spcPct val="145000"/>
+              </a:lnSpc>
+              <a:spcBef>
+                <a:spcPts val="0"/>
+              </a:spcBef>
+              <a:spcAft>
+                <a:spcPts val="0"/>
+              </a:spcAft>
+              <a:defRPr sz="1100" u="none">
+                <a:solidFill>
+                  <a:srgbClr val="5C7182"/>
+                </a:solidFill>
+                <a:latin typeface="Hiragino Sans"/>
+              </a:defRPr>
+            </a:pPr>
+            <a:r>
+              <a:t>起動・通信・復帰の段階を115200bpsで記録。</a:t>
+            </a:r>
+          </a:p>
+          <a:p>
+            <a:pPr>
+              <a:lnSpc>
+                <a:spcPct val="145000"/>
+              </a:lnSpc>
+              <a:spcBef>
+                <a:spcPts val="0"/>
+              </a:spcBef>
+              <a:spcAft>
+                <a:spcPts val="0"/>
+              </a:spcAft>
+              <a:defRPr sz="1100" u="none">
+                <a:solidFill>
+                  <a:srgbClr val="5C7182"/>
+                </a:solidFill>
+                <a:latin typeface="Hiragino Sans"/>
+              </a:defRPr>
+            </a:pPr>
+            <a:r>
+              <a:t>コード本文・Wi-Fi情報・キーは記録しません。</a:t>
+            </a:r>
+          </a:p>
+        </p:txBody>
+      </p:sp>
+      <p:sp>
+        <p:nvSpPr>
+          <p:cNvPr id="12" name="TextBox 11"/>
+          <p:cNvSpPr txBox="1"/>
+          <p:nvPr/>
+        </p:nvSpPr>
+        <p:spPr>
+          <a:xfrm>
+            <a:off x="6629400" y="1981200"/>
+            <a:ext cx="5029200" cy="382270"/>
+          </a:xfrm>
+          <a:prstGeom prst="rect">
+            <a:avLst/>
+          </a:prstGeom>
+          <a:noFill/>
+        </p:spPr>
+        <p:txBody>
+          <a:bodyPr wrap="none" lIns="0" rIns="0" tIns="0" bIns="0">
+            <a:spAutoFit/>
+          </a:bodyPr>
+          <a:lstStyle/>
+          <a:p>
+            <a:pPr>
+              <a:lnSpc>
+                <a:spcPct val="145000"/>
+              </a:lnSpc>
+              <a:spcBef>
+                <a:spcPts val="0"/>
+              </a:spcBef>
+              <a:spcAft>
+                <a:spcPts val="0"/>
+              </a:spcAft>
+              <a:defRPr sz="1800" u="none">
+                <a:solidFill>
+                  <a:srgbClr val="356FF0"/>
+                </a:solidFill>
+                <a:latin typeface="Hiragino Sans"/>
+              </a:defRPr>
+            </a:pPr>
+            <a:r>
+              <a:t>確認中と停止時の表示</a:t>
+            </a:r>
+          </a:p>
+        </p:txBody>
+      </p:sp>
+      <p:sp>
+        <p:nvSpPr>
+          <p:cNvPr id="13" name="TextBox 12"/>
+          <p:cNvSpPr txBox="1"/>
+          <p:nvPr/>
+        </p:nvSpPr>
+        <p:spPr>
+          <a:xfrm>
+            <a:off x="6629400" y="2438400"/>
+            <a:ext cx="5029200" cy="1247775"/>
+          </a:xfrm>
+          <a:prstGeom prst="rect">
+            <a:avLst/>
+          </a:prstGeom>
+          <a:noFill/>
+        </p:spPr>
+        <p:txBody>
+          <a:bodyPr wrap="none" lIns="0" rIns="0" tIns="0" bIns="0">
+            <a:spAutoFit/>
+          </a:bodyPr>
+          <a:lstStyle/>
+          <a:p>
+            <a:pPr>
+              <a:lnSpc>
+                <a:spcPct val="145000"/>
+              </a:lnSpc>
+              <a:spcBef>
+                <a:spcPts val="0"/>
+              </a:spcBef>
+              <a:spcAft>
+                <a:spcPts val="0"/>
+              </a:spcAft>
+              <a:defRPr sz="1300" u="none">
+                <a:solidFill>
+                  <a:srgbClr val="132333"/>
+                </a:solidFill>
+                <a:latin typeface="Hiragino Sans"/>
+              </a:defRPr>
+            </a:pPr>
+            <a:r>
+              <a:t>STARTING / READER RESUME：復帰確認中</a:t>
+            </a:r>
+          </a:p>
+          <a:p>
+            <a:pPr>
+              <a:lnSpc>
+                <a:spcPct val="145000"/>
+              </a:lnSpc>
+              <a:spcBef>
+                <a:spcPts val="0"/>
+              </a:spcBef>
+              <a:spcAft>
+                <a:spcPts val="0"/>
+              </a:spcAft>
+              <a:defRPr sz="1300" u="none">
+                <a:solidFill>
+                  <a:srgbClr val="132333"/>
+                </a:solidFill>
+                <a:latin typeface="Hiragino Sans"/>
+              </a:defRPr>
+            </a:pPr>
+            <a:r>
+              <a:t>ERROR / RECOVERY HOLD：復帰未確認</a:t>
+            </a:r>
+          </a:p>
+          <a:p>
+            <a:pPr>
+              <a:lnSpc>
+                <a:spcPct val="145000"/>
+              </a:lnSpc>
+              <a:spcBef>
+                <a:spcPts val="0"/>
+              </a:spcBef>
+              <a:spcAft>
+                <a:spcPts val="0"/>
+              </a:spcAft>
+              <a:defRPr sz="1300" u="none">
+                <a:solidFill>
+                  <a:srgbClr val="132333"/>
+                </a:solidFill>
+                <a:latin typeface="Hiragino Sans"/>
+              </a:defRPr>
+            </a:pPr>
+            <a:r>
+              <a:t>READER STORAGE：復帰の記録保存に失敗</a:t>
+            </a:r>
+          </a:p>
+          <a:p>
+            <a:pPr>
+              <a:lnSpc>
+                <a:spcPct val="145000"/>
+              </a:lnSpc>
+              <a:spcBef>
+                <a:spcPts val="0"/>
+              </a:spcBef>
+              <a:spcAft>
+                <a:spcPts val="0"/>
+              </a:spcAft>
+              <a:defRPr sz="1300" u="none">
+                <a:solidFill>
+                  <a:srgbClr val="132333"/>
+                </a:solidFill>
+                <a:latin typeface="Hiragino Sans"/>
+              </a:defRPr>
+            </a:pPr>
+            <a:r>
+              <a:t>READER POWER / BUS / I2C：給電・通信</a:t>
+            </a:r>
+          </a:p>
+          <a:p>
+            <a:pPr>
+              <a:lnSpc>
+                <a:spcPct val="145000"/>
+              </a:lnSpc>
+              <a:spcBef>
+                <a:spcPts val="0"/>
+              </a:spcBef>
+              <a:spcAft>
+                <a:spcPts val="0"/>
+              </a:spcAft>
+              <a:defRPr sz="1300" u="none">
+                <a:solidFill>
+                  <a:srgbClr val="132333"/>
+                </a:solidFill>
+                <a:latin typeface="Hiragino Sans"/>
+              </a:defRPr>
+            </a:pPr>
+            <a:r>
+              <a:t>READER CONFIG：版・設定・TRIG読戻し</a:t>
+            </a:r>
+          </a:p>
+        </p:txBody>
+      </p:sp>
+      <p:sp>
+        <p:nvSpPr>
+          <p:cNvPr id="14" name="TextBox 13"/>
+          <p:cNvSpPr txBox="1"/>
+          <p:nvPr/>
+        </p:nvSpPr>
+        <p:spPr>
+          <a:xfrm>
+            <a:off x="6629400" y="3810000"/>
+            <a:ext cx="5029200" cy="1376680"/>
+          </a:xfrm>
+          <a:prstGeom prst="rect">
+            <a:avLst/>
+          </a:prstGeom>
+          <a:noFill/>
+        </p:spPr>
+        <p:txBody>
+          <a:bodyPr wrap="none" lIns="0" rIns="0" tIns="0" bIns="0">
+            <a:spAutoFit/>
+          </a:bodyPr>
+          <a:lstStyle/>
+          <a:p>
+            <a:pPr>
+              <a:lnSpc>
+                <a:spcPct val="145000"/>
+              </a:lnSpc>
+              <a:spcBef>
+                <a:spcPts val="0"/>
+              </a:spcBef>
+              <a:spcAft>
+                <a:spcPts val="0"/>
+              </a:spcAft>
+              <a:defRPr sz="1200" u="none">
+                <a:solidFill>
+                  <a:srgbClr val="5C7182"/>
+                </a:solidFill>
+                <a:latin typeface="Hiragino Sans"/>
+              </a:defRPr>
+            </a:pPr>
+            <a:r>
+              <a:t>復帰命令の前に確認待ちを端末へ保存。</a:t>
+            </a:r>
+          </a:p>
+          <a:p>
+            <a:pPr>
+              <a:lnSpc>
+                <a:spcPct val="145000"/>
+              </a:lnSpc>
+              <a:spcBef>
+                <a:spcPts val="0"/>
+              </a:spcBef>
+              <a:spcAft>
+                <a:spcPts val="0"/>
+              </a:spcAft>
+              <a:defRPr sz="1200" u="none">
+                <a:solidFill>
+                  <a:srgbClr val="5C7182"/>
+                </a:solidFill>
+                <a:latin typeface="Hiragino Sans"/>
+              </a:defRPr>
+            </a:pPr>
+            <a:r>
+              <a:t>失敗や本体再起動後も0x54を再確認せず、</a:t>
+            </a:r>
+          </a:p>
+          <a:p>
+            <a:pPr>
+              <a:lnSpc>
+                <a:spcPct val="145000"/>
+              </a:lnSpc>
+              <a:spcBef>
+                <a:spcPts val="0"/>
+              </a:spcBef>
+              <a:spcAft>
+                <a:spcPts val="0"/>
+              </a:spcAft>
+              <a:defRPr sz="1200" u="none">
+                <a:solidFill>
+                  <a:srgbClr val="5C7182"/>
+                </a:solidFill>
+                <a:latin typeface="Hiragino Sans"/>
+              </a:defRPr>
+            </a:pPr>
+            <a:r>
+              <a:t>命令を再送しません。正常0x21の設定まで</a:t>
+            </a:r>
+          </a:p>
+          <a:p>
+            <a:pPr>
+              <a:lnSpc>
+                <a:spcPct val="145000"/>
+              </a:lnSpc>
+              <a:spcBef>
+                <a:spcPts val="0"/>
+              </a:spcBef>
+              <a:spcAft>
+                <a:spcPts val="0"/>
+              </a:spcAft>
+              <a:defRPr sz="1200" u="none">
+                <a:solidFill>
+                  <a:srgbClr val="5C7182"/>
+                </a:solidFill>
+                <a:latin typeface="Hiragino Sans"/>
+              </a:defRPr>
+            </a:pPr>
+            <a:r>
+              <a:t>確認できた場合だけ記録を解除します。</a:t>
+            </a:r>
+          </a:p>
+          <a:p>
+            <a:pPr>
+              <a:lnSpc>
+                <a:spcPct val="145000"/>
+              </a:lnSpc>
+              <a:spcBef>
+                <a:spcPts val="0"/>
+              </a:spcBef>
+              <a:spcAft>
+                <a:spcPts val="0"/>
+              </a:spcAft>
+              <a:defRPr sz="1200" u="none">
+                <a:solidFill>
+                  <a:srgbClr val="5C7182"/>
+                </a:solidFill>
+                <a:latin typeface="Hiragino Sans"/>
+              </a:defRPr>
+            </a:pPr>
+            <a:r>
+              <a:t>Aボタンで再試行せず、ログを確認します。</a:t>
+            </a:r>
+          </a:p>
+          <a:p>
+            <a:pPr>
+              <a:lnSpc>
+                <a:spcPct val="145000"/>
+              </a:lnSpc>
+              <a:spcBef>
+                <a:spcPts val="0"/>
+              </a:spcBef>
+              <a:spcAft>
+                <a:spcPts val="0"/>
+              </a:spcAft>
+              <a:defRPr sz="1200" u="none">
+                <a:solidFill>
+                  <a:srgbClr val="5C7182"/>
+                </a:solidFill>
+                <a:latin typeface="Hiragino Sans"/>
+              </a:defRPr>
+            </a:pPr>
+            <a:r>
+              <a:t>未送信イベントは保持。全消去しないでください。</a:t>
+            </a:r>
+          </a:p>
+        </p:txBody>
+      </p:sp>
+      <p:sp>
+        <p:nvSpPr>
+          <p:cNvPr id="15" name="TextBox 14"/>
+          <p:cNvSpPr txBox="1"/>
+          <p:nvPr/>
+        </p:nvSpPr>
+        <p:spPr>
+          <a:xfrm>
+            <a:off x="533400" y="5600700"/>
+            <a:ext cx="11125200" cy="492759"/>
+          </a:xfrm>
+          <a:prstGeom prst="rect">
+            <a:avLst/>
+          </a:prstGeom>
+          <a:noFill/>
+        </p:spPr>
+        <p:txBody>
+          <a:bodyPr wrap="none" lIns="0" rIns="0" tIns="0" bIns="0">
+            <a:spAutoFit/>
+          </a:bodyPr>
+          <a:lstStyle/>
+          <a:p>
+            <a:pPr>
+              <a:lnSpc>
+                <a:spcPct val="145000"/>
+              </a:lnSpc>
+              <a:spcBef>
+                <a:spcPts val="0"/>
+              </a:spcBef>
+              <a:spcAft>
+                <a:spcPts val="0"/>
+              </a:spcAft>
+              <a:defRPr sz="1200" u="none">
+                <a:solidFill>
+                  <a:srgbClr val="132333"/>
+                </a:solidFill>
+                <a:latin typeface="Hiragino Sans"/>
+              </a:defRPr>
+            </a:pPr>
+            <a:r>
+              <a:t>ブート復帰は実機未検証です。Unit起動時の不調を対象とし、スキャン中の異常とは区別します。</a:t>
+            </a:r>
+          </a:p>
+          <a:p>
+            <a:pPr>
+              <a:lnSpc>
+                <a:spcPct val="145000"/>
+              </a:lnSpc>
+              <a:spcBef>
+                <a:spcPts val="0"/>
+              </a:spcBef>
+              <a:spcAft>
+                <a:spcPts val="0"/>
+              </a:spcAft>
+              <a:defRPr sz="1200" u="none">
+                <a:solidFill>
+                  <a:srgbClr val="132333"/>
+                </a:solidFill>
+                <a:latin typeface="Hiragino Sans"/>
+              </a:defRPr>
+            </a:pPr>
+            <a:r>
+              <a:t>電源原因の確定や再発防止の実証とは扱わず、READY・実読取り・Scans保存を別々に確認します。</a:t>
+            </a:r>
+          </a:p>
+        </p:txBody>
+      </p:sp>
+      <p:sp>
+        <p:nvSpPr>
+          <p:cNvPr id="16" name="TextBox 15"/>
+          <p:cNvSpPr txBox="1"/>
+          <p:nvPr/>
+        </p:nvSpPr>
+        <p:spPr>
+          <a:xfrm>
+            <a:off x="533400" y="6553200"/>
+            <a:ext cx="3556000" cy="234950"/>
+          </a:xfrm>
+          <a:prstGeom prst="rect">
+            <a:avLst/>
+          </a:prstGeom>
+          <a:noFill/>
+        </p:spPr>
+        <p:txBody>
+          <a:bodyPr wrap="none" lIns="0" rIns="0" tIns="0" bIns="0">
+            <a:spAutoFit/>
+          </a:bodyPr>
+          <a:lstStyle/>
+          <a:p>
+            <a:pPr>
+              <a:lnSpc>
+                <a:spcPct val="145000"/>
+              </a:lnSpc>
+              <a:spcBef>
+                <a:spcPts val="0"/>
+              </a:spcBef>
+              <a:spcAft>
+                <a:spcPts val="0"/>
+              </a:spcAft>
+              <a:defRPr sz="1000" u="none">
+                <a:solidFill>
+                  <a:srgbClr val="5C7182"/>
+                </a:solidFill>
+                <a:latin typeface="Hiragino Sans"/>
+              </a:defRPr>
+            </a:pPr>
+            <a:r>
+              <a:t>M5Stack 在庫管理システム</a:t>
+            </a:r>
+          </a:p>
+        </p:txBody>
+      </p:sp>
+      <p:sp>
+        <p:nvSpPr>
+          <p:cNvPr id="17" name="TextBox 16"/>
+          <p:cNvSpPr txBox="1"/>
+          <p:nvPr/>
+        </p:nvSpPr>
+        <p:spPr>
+          <a:xfrm>
+            <a:off x="4635500" y="6553200"/>
+            <a:ext cx="5461000" cy="234950"/>
+          </a:xfrm>
+          <a:prstGeom prst="rect">
+            <a:avLst/>
+          </a:prstGeom>
+          <a:noFill/>
+        </p:spPr>
+        <p:txBody>
+          <a:bodyPr wrap="none" lIns="0" rIns="0" tIns="0" bIns="0">
+            <a:spAutoFit/>
+          </a:bodyPr>
+          <a:lstStyle/>
+          <a:p>
+            <a:pPr>
+              <a:lnSpc>
+                <a:spcPct val="145000"/>
+              </a:lnSpc>
+              <a:spcBef>
+                <a:spcPts val="0"/>
+              </a:spcBef>
+              <a:spcAft>
+                <a:spcPts val="0"/>
+              </a:spcAft>
+              <a:defRPr sz="1000" u="none">
+                <a:solidFill>
+                  <a:srgbClr val="5C7182"/>
+                </a:solidFill>
+                <a:latin typeface="Hiragino Sans"/>
+              </a:defRPr>
+            </a:pPr>
+            <a:r>
+              <a:t>© 2026 K Visualization Studio</a:t>
+            </a:r>
+          </a:p>
+        </p:txBody>
+      </p:sp>
+      <p:sp>
+        <p:nvSpPr>
+          <p:cNvPr id="18" name="TextBox 17"/>
+          <p:cNvSpPr txBox="1"/>
+          <p:nvPr/>
+        </p:nvSpPr>
+        <p:spPr>
+          <a:xfrm>
+            <a:off x="11150600" y="6553200"/>
+            <a:ext cx="508000" cy="234950"/>
+          </a:xfrm>
+          <a:prstGeom prst="rect">
+            <a:avLst/>
+          </a:prstGeom>
+          <a:noFill/>
+        </p:spPr>
+        <p:txBody>
+          <a:bodyPr wrap="none" lIns="0" rIns="0" tIns="0" bIns="0">
+            <a:spAutoFit/>
+          </a:bodyPr>
+          <a:lstStyle/>
+          <a:p>
+            <a:pPr>
+              <a:lnSpc>
+                <a:spcPct val="145000"/>
+              </a:lnSpc>
+              <a:spcBef>
+                <a:spcPts val="0"/>
+              </a:spcBef>
+              <a:spcAft>
+                <a:spcPts val="0"/>
+              </a:spcAft>
+              <a:defRPr sz="1000" u="none">
+                <a:solidFill>
+                  <a:srgbClr val="5C7182"/>
+                </a:solidFill>
+                <a:latin typeface="Hiragino Sans"/>
+              </a:defRPr>
+            </a:pPr>
+            <a:r>
+              <a:t>23</a:t>
+            </a:r>
+          </a:p>
+        </p:txBody>
+      </p:sp>
+    </p:spTree>
+  </p:cSld>
+  <p:clrMapOvr>
+    <a:masterClrMapping/>
+  </p:clrMapOvr>
+</p:sld>
+</file>
+
 <file path=ppt/slides/slide3.xml><?xml version="1.0" encoding="utf-8"?>
 <p:sld xmlns:p="http://schemas.openxmlformats.org/presentationml/2006/main">
   <p:cSld>

</xml_diff>

<commit_message>
Separate Unit QRCode command replies from inventory scans
</commit_message>
<xml_diff>
--- a/docs/M5Stack_Inventory_Guide.pptx
+++ b/docs/M5Stack_Inventory_Guide.pptx
@@ -28428,8 +28428,8 @@
         </p:nvSpPr>
         <p:spPr>
           <a:xfrm>
-            <a:off x="533400" y="5600700"/>
-            <a:ext cx="11125200" cy="492759"/>
+            <a:off x="533400" y="5524500"/>
+            <a:ext cx="11125200" cy="713740"/>
           </a:xfrm>
           <a:prstGeom prst="rect">
             <a:avLst/>
@@ -28483,6 +28483,28 @@
             </a:pPr>
             <a:r>
               <a:t>電源原因の確定や再発防止の実証とは扱わず、READY・実読取り・Scans保存を別々に確認します。</a:t>
+            </a:r>
+          </a:p>
+          <a:p>
+            <a:pPr>
+              <a:lnSpc>
+                <a:spcPct val="145000"/>
+              </a:lnSpc>
+              <a:spcBef>
+                <a:spcPts val="0"/>
+              </a:spcBef>
+              <a:spcAft>
+                <a:spcPts val="0"/>
+              </a:spcAft>
+              <a:defRPr sz="1200" u="none">
+                <a:solidFill>
+                  <a:srgbClr val="132333"/>
+                </a:solidFill>
+                <a:latin typeface="Hiragino Sans"/>
+              </a:defRPr>
+            </a:pPr>
+            <a:r>
+              <a:t>TRIG未操作のCONTROL BYTESは読取りデータ検査の表示です。起動復帰・電源原因とは分けて確認します。</a:t>
             </a:r>
           </a:p>
         </p:txBody>

</xml_diff>

<commit_message>
Ignore reader command replies before inventory scan handling (#5)
* Separate Unit QRCode command replies from inventory scans

* Update Arduino archive at the documented download path

* Clarify remaining reader reply verification limits

---------

Co-authored-by: TikTak007 <TikTak007@users.noreply.github.com>
</commit_message>
<xml_diff>
--- a/docs/M5Stack_Inventory_Guide.pptx
+++ b/docs/M5Stack_Inventory_Guide.pptx
@@ -28428,8 +28428,8 @@
         </p:nvSpPr>
         <p:spPr>
           <a:xfrm>
-            <a:off x="533400" y="5600700"/>
-            <a:ext cx="11125200" cy="492759"/>
+            <a:off x="533400" y="5524500"/>
+            <a:ext cx="11125200" cy="713740"/>
           </a:xfrm>
           <a:prstGeom prst="rect">
             <a:avLst/>
@@ -28483,6 +28483,28 @@
             </a:pPr>
             <a:r>
               <a:t>電源原因の確定や再発防止の実証とは扱わず、READY・実読取り・Scans保存を別々に確認します。</a:t>
+            </a:r>
+          </a:p>
+          <a:p>
+            <a:pPr>
+              <a:lnSpc>
+                <a:spcPct val="145000"/>
+              </a:lnSpc>
+              <a:spcBef>
+                <a:spcPts val="0"/>
+              </a:spcBef>
+              <a:spcAft>
+                <a:spcPts val="0"/>
+              </a:spcAft>
+              <a:defRPr sz="1200" u="none">
+                <a:solidFill>
+                  <a:srgbClr val="132333"/>
+                </a:solidFill>
+                <a:latin typeface="Hiragino Sans"/>
+              </a:defRPr>
+            </a:pPr>
+            <a:r>
+              <a:t>TRIG未操作のCONTROL BYTESは読取りデータ検査の表示です。起動復帰・電源原因とは分けて確認します。</a:t>
             </a:r>
           </a:p>
         </p:txBody>

</xml_diff>